<commit_message>
simplify field rep login and doctor addition docs
</commit_message>
<xml_diff>
--- a/output/doc/user-flow-decks/00-user-flow-training-index.pptx
+++ b/output/doc/user-flow-decks/00-user-flow-training-index.pptx
@@ -3844,7 +3844,7 @@
                 <a:latin typeface="Aptos"/>
                 <a:hlinkClick r:id="rId7"/>
               </a:rPr>
-              <a:t>06. Field Rep Registration and Login</a:t>
+              <a:t>06. Field Rep Login</a:t>
             </a:r>
           </a:p>
           <a:p>
@@ -3892,7 +3892,7 @@
                 <a:latin typeface="Aptos"/>
                 <a:hlinkClick r:id="rId8"/>
               </a:rPr>
-              <a:t>07. Field Rep Sharing and Doctor Bulk Upload</a:t>
+              <a:t>07. Field Rep Sharing and Doctor Addition</a:t>
             </a:r>
           </a:p>
           <a:p>

</xml_diff>